<commit_message>
Update pitch deck and AI log for drum kit and chord synth
Co-Authored-By: Claude Sonnet 5.5 <noreply@anthropic.com>
Claude-Session: https://claude.ai/code/session_01AzxfnqnDqs4Fac34LnmeNV
</commit_message>
<xml_diff>
--- a/Docs/Pitch/SoundSpace-Pitch.pptx
+++ b/Docs/Pitch/SoundSpace-Pitch.pptx
@@ -2074,6 +2074,10 @@
             <a:prstDash val="solid"/>
           </a:ln>
         </p:spPr>
+        <p:txBody>
+          <a:bodyPr/>
+          <a:p/>
+        </p:txBody>
       </p:sp>
       <p:sp>
         <p:nvSpPr>
@@ -2101,6 +2105,10 @@
             <a:prstDash val="solid"/>
           </a:ln>
         </p:spPr>
+        <p:txBody>
+          <a:bodyPr/>
+          <a:p/>
+        </p:txBody>
       </p:sp>
       <p:sp>
         <p:nvSpPr>
@@ -2128,6 +2136,10 @@
             <a:prstDash val="solid"/>
           </a:ln>
         </p:spPr>
+        <p:txBody>
+          <a:bodyPr/>
+          <a:p/>
+        </p:txBody>
       </p:sp>
       <p:sp>
         <p:nvSpPr>
@@ -2155,6 +2167,10 @@
             <a:prstDash val="solid"/>
           </a:ln>
         </p:spPr>
+        <p:txBody>
+          <a:bodyPr/>
+          <a:p/>
+        </p:txBody>
       </p:sp>
       <p:sp>
         <p:nvSpPr>
@@ -2225,7 +2241,7 @@
                   <a:schemeClr val="accent2"/>
                 </a:solidFill>
               </a:rPr>
-              <a:t>Play Sri Lankan rhythms all around you</a:t>
+              <a:t>Jam on a drum kit and chords, all around you</a:t>
             </a:r>
             <a:endParaRPr lang="en-US" sz="2400" dirty="0"/>
           </a:p>
@@ -2753,7 +2769,7 @@
                             <a:schemeClr val="tx1"/>
                           </a:solidFill>
                         </a:rPr>
-                        <a:t>Partner academy; record real drummers; teachers review lessons</a:t>
+                        <a:t>Record real drummers and chords; teachers review lessons</a:t>
                       </a:r>
                       <a:endParaRPr lang="en-US" sz="1300" dirty="0"/>
                     </a:p>
@@ -3169,6 +3185,10 @@
             <a:prstDash val="solid"/>
           </a:ln>
         </p:spPr>
+        <p:txBody>
+          <a:bodyPr/>
+          <a:p/>
+        </p:txBody>
       </p:sp>
       <p:sp>
         <p:nvSpPr>
@@ -3194,6 +3214,10 @@
             <a:prstDash val="solid"/>
           </a:ln>
         </p:spPr>
+        <p:txBody>
+          <a:bodyPr/>
+          <a:p/>
+        </p:txBody>
       </p:sp>
       <p:sp>
         <p:nvSpPr>
@@ -3264,7 +3288,7 @@
                   <a:schemeClr val="tx1"/>
                 </a:solidFill>
               </a:rPr>
-              <a:t>Prototype: 4 instruments, loop, one lesson</a:t>
+              <a:t>Prototype: drum kit, chord synth, loop, lessons</a:t>
             </a:r>
             <a:endParaRPr lang="en-US" sz="1400" dirty="0"/>
           </a:p>
@@ -3933,7 +3957,7 @@
                 <a:ea typeface="Cambria" pitchFamily="34" charset="-122"/>
                 <a:cs typeface="Cambria" pitchFamily="34" charset="-120"/>
               </a:rPr>
-              <a:t>Traditional drums are hard to reach</a:t>
+              <a:t>Learning to jam is hard to start</a:t>
             </a:r>
             <a:endParaRPr lang="en-US" sz="3600" dirty="0"/>
           </a:p>
@@ -3963,6 +3987,10 @@
             <a:prstDash val="solid"/>
           </a:ln>
         </p:spPr>
+        <p:txBody>
+          <a:bodyPr/>
+          <a:p/>
+        </p:txBody>
       </p:sp>
       <p:sp>
         <p:nvSpPr>
@@ -4066,7 +4094,7 @@
                   <a:srgbClr val="4A3B33"/>
                 </a:solidFill>
               </a:rPr>
-              <a:t>A geta bera or rabana costs money, needs space and annoys neighbours.</a:t>
+              <a:t>A real drum kit costs money, needs space and annoys the neighbours.</a:t>
             </a:r>
             <a:endParaRPr lang="en-US" sz="1600" dirty="0"/>
           </a:p>
@@ -4096,6 +4124,10 @@
             <a:prstDash val="solid"/>
           </a:ln>
         </p:spPr>
+        <p:txBody>
+          <a:bodyPr/>
+          <a:p/>
+        </p:txBody>
       </p:sp>
       <p:sp>
         <p:nvSpPr>
@@ -4163,7 +4195,7 @@
                   <a:schemeClr val="tx1"/>
                 </a:solidFill>
               </a:rPr>
-              <a:t>Needs a teacher</a:t>
+              <a:t>Needs a band</a:t>
             </a:r>
             <a:endParaRPr lang="en-US" sz="2000" dirty="0"/>
           </a:p>
@@ -4199,7 +4231,7 @@
                   <a:srgbClr val="4A3B33"/>
                 </a:solidFill>
               </a:rPr>
-              <a:t>Rhythms are passed on in person. Few teachers, mostly in a few cities.</a:t>
+              <a:t>Playing drums over chord changes usually means finding other musicians.</a:t>
             </a:r>
             <a:endParaRPr lang="en-US" sz="1600" dirty="0"/>
           </a:p>
@@ -4229,6 +4261,10 @@
             <a:prstDash val="solid"/>
           </a:ln>
         </p:spPr>
+        <p:txBody>
+          <a:bodyPr/>
+          <a:p/>
+        </p:txBody>
       </p:sp>
       <p:sp>
         <p:nvSpPr>
@@ -4296,7 +4332,7 @@
                   <a:schemeClr val="tx1"/>
                 </a:solidFill>
               </a:rPr>
-              <a:t>Almost no digital version</a:t>
+              <a:t>Nothing feels like a kit</a:t>
             </a:r>
             <a:endParaRPr lang="en-US" sz="2000" dirty="0"/>
           </a:p>
@@ -4332,7 +4368,7 @@
                   <a:srgbClr val="4A3B33"/>
                 </a:solidFill>
               </a:rPr>
-              <a:t>Music apps are built around Western instruments and flat screens.</a:t>
+              <a:t>Phone and tablet kits are tiny taps on glass, not real playing.</a:t>
             </a:r>
             <a:endParaRPr lang="en-US" sz="1600" dirty="0"/>
           </a:p>
@@ -4441,7 +4477,7 @@
                 <a:ea typeface="Cambria" pitchFamily="34" charset="-122"/>
                 <a:cs typeface="Cambria" pitchFamily="34" charset="-120"/>
               </a:rPr>
-              <a:t>Life-size drums, in your own room</a:t>
+              <a:t>A drum kit and chord synth, in your own room</a:t>
             </a:r>
             <a:endParaRPr lang="en-US" sz="3600" dirty="0"/>
           </a:p>
@@ -4473,6 +4509,10 @@
             <a:prstDash val="solid"/>
           </a:ln>
         </p:spPr>
+        <p:txBody>
+          <a:bodyPr/>
+          <a:p/>
+        </p:txBody>
       </p:sp>
       <p:sp>
         <p:nvSpPr>
@@ -4507,7 +4547,7 @@
                 <a:ea typeface="Cambria" pitchFamily="34" charset="-122"/>
                 <a:cs typeface="Cambria" pitchFamily="34" charset="-120"/>
               </a:rPr>
-              <a:t>Look and pinch</a:t>
+              <a:t>Strike the kit</a:t>
             </a:r>
             <a:endParaRPr lang="en-US" sz="1800" dirty="0"/>
           </a:p>
@@ -4543,7 +4583,7 @@
                   <a:schemeClr val="tx1"/>
                 </a:solidFill>
               </a:rPr>
-              <a:t>Look at a drum and pinch to strike it, the way Vision Pro is meant to be used.</a:t>
+              <a:t>A life-size kit with kick, snare, hi-hat, toms, crash and ride. Look and pinch to hit each piece.</a:t>
             </a:r>
             <a:endParaRPr lang="en-US" sz="1400" dirty="0"/>
           </a:p>
@@ -4575,6 +4615,10 @@
             <a:prstDash val="solid"/>
           </a:ln>
         </p:spPr>
+        <p:txBody>
+          <a:bodyPr/>
+          <a:p/>
+        </p:txBody>
       </p:sp>
       <p:sp>
         <p:nvSpPr>
@@ -4677,6 +4721,10 @@
             <a:prstDash val="solid"/>
           </a:ln>
         </p:spPr>
+        <p:txBody>
+          <a:bodyPr/>
+          <a:p/>
+        </p:txBody>
       </p:sp>
       <p:sp>
         <p:nvSpPr>
@@ -4711,7 +4759,7 @@
                 <a:ea typeface="Cambria" pitchFamily="34" charset="-122"/>
                 <a:cs typeface="Cambria" pitchFamily="34" charset="-120"/>
               </a:rPr>
-              <a:t>Loops and lessons</a:t>
+              <a:t>Chords, loops, lessons</a:t>
             </a:r>
             <a:endParaRPr lang="en-US" sz="1800" dirty="0"/>
           </a:p>
@@ -4747,7 +4795,7 @@
                   <a:schemeClr val="tx1"/>
                 </a:solidFill>
               </a:rPr>
-              <a:t>Record an 8-beat loop, then follow a lesson where the next drum pulses before you hit it.</a:t>
+              <a:t>Build a four-bar chord progression, play drums over it, record a loop, or follow a lesson.</a:t>
             </a:r>
             <a:endParaRPr lang="en-US" sz="1400" dirty="0"/>
           </a:p>
@@ -5294,6 +5342,10 @@
             <a:prstDash val="solid"/>
           </a:ln>
         </p:spPr>
+        <p:txBody>
+          <a:bodyPr/>
+          <a:p/>
+        </p:txBody>
       </p:sp>
       <p:sp>
         <p:nvSpPr>
@@ -5364,7 +5416,7 @@
                   <a:srgbClr val="FFFFFF"/>
                 </a:solidFill>
               </a:rPr>
-              <a:t>A drum the size of a drum.</a:t>
+              <a:t>A kit the size of a kit.</a:t>
             </a:r>
             <a:endParaRPr lang="en-US" sz="1400" dirty="0"/>
           </a:p>
@@ -5811,6 +5863,10 @@
             <a:prstDash val="solid"/>
           </a:ln>
         </p:spPr>
+        <p:txBody>
+          <a:bodyPr/>
+          <a:p/>
+        </p:txBody>
       </p:sp>
       <p:sp>
         <p:nvSpPr>
@@ -5881,7 +5937,7 @@
                   <a:schemeClr val="tx1"/>
                 </a:solidFill>
               </a:rPr>
-              <a:t>Students and hobbyists curious about traditional percussion.</a:t>
+              <a:t>Students and hobbyists who want to jam without a band.</a:t>
             </a:r>
             <a:endParaRPr lang="en-US" sz="1400" dirty="0"/>
           </a:p>
@@ -5913,6 +5969,10 @@
             <a:prstDash val="solid"/>
           </a:ln>
         </p:spPr>
+        <p:txBody>
+          <a:bodyPr/>
+          <a:p/>
+        </p:txBody>
       </p:sp>
       <p:sp>
         <p:nvSpPr>
@@ -5983,7 +6043,7 @@
                   <a:schemeClr val="tx1"/>
                 </a:solidFill>
               </a:rPr>
-              <a:t>Aesthetic-music classes and music schools that cannot stock every instrument.</a:t>
+              <a:t>Music classes and schools that cannot stock a kit for every student.</a:t>
             </a:r>
             <a:endParaRPr lang="en-US" sz="1400" dirty="0"/>
           </a:p>
@@ -6015,6 +6075,10 @@
             <a:prstDash val="solid"/>
           </a:ln>
         </p:spPr>
+        <p:txBody>
+          <a:bodyPr/>
+          <a:p/>
+        </p:txBody>
       </p:sp>
       <p:sp>
         <p:nvSpPr>
@@ -6049,7 +6113,7 @@
                 <a:ea typeface="Cambria" pitchFamily="34" charset="-122"/>
                 <a:cs typeface="Cambria" pitchFamily="34" charset="-120"/>
               </a:rPr>
-              <a:t>Diaspora families</a:t>
+              <a:t>Bedroom musicians</a:t>
             </a:r>
             <a:endParaRPr lang="en-US" sz="1800" dirty="0"/>
           </a:p>
@@ -6085,7 +6149,7 @@
                   <a:schemeClr val="tx1"/>
                 </a:solidFill>
               </a:rPr>
-              <a:t>Sri Lankans abroad who want children to meet the culture.</a:t>
+              <a:t>Players in small flats who cannot make noise.</a:t>
             </a:r>
             <a:endParaRPr lang="en-US" sz="1400" dirty="0"/>
           </a:p>
@@ -6117,6 +6181,10 @@
             <a:prstDash val="solid"/>
           </a:ln>
         </p:spPr>
+        <p:txBody>
+          <a:bodyPr/>
+          <a:p/>
+        </p:txBody>
       </p:sp>
       <p:sp>
         <p:nvSpPr>
@@ -6151,7 +6219,7 @@
                 <a:ea typeface="Cambria" pitchFamily="34" charset="-122"/>
                 <a:cs typeface="Cambria" pitchFamily="34" charset="-120"/>
               </a:rPr>
-              <a:t>Museums and cultural tourism</a:t>
+              <a:t>Museums and venues</a:t>
             </a:r>
             <a:endParaRPr lang="en-US" sz="1800" dirty="0"/>
           </a:p>
@@ -6187,7 +6255,7 @@
                   <a:schemeClr val="tx1"/>
                 </a:solidFill>
               </a:rPr>
-              <a:t>Interactive exhibits and festival experiences.</a:t>
+              <a:t>Interactive music exhibits and events.</a:t>
             </a:r>
             <a:endParaRPr lang="en-US" sz="1400" dirty="0"/>
           </a:p>
@@ -6645,7 +6713,7 @@
                             <a:schemeClr val="tx1"/>
                           </a:solidFill>
                         </a:rPr>
-                        <a:t>No acoustic or traditional instruments</a:t>
+                        <a:t>Few traditional instruments; no chord-and-drum jamming</a:t>
                       </a:r>
                       <a:endParaRPr lang="en-US" sz="1300" dirty="0"/>
                     </a:p>
@@ -6821,7 +6889,7 @@
                             <a:schemeClr val="tx1"/>
                           </a:solidFill>
                         </a:rPr>
-                        <a:t>Western kits; no South Asian drums or lessons</a:t>
+                        <a:t>Not built around playing along to your own chord progression</a:t>
                       </a:r>
                       <a:endParaRPr lang="en-US" sz="1300" dirty="0"/>
                     </a:p>
@@ -7349,7 +7417,7 @@
                             <a:schemeClr val="tx1"/>
                           </a:solidFill>
                         </a:rPr>
-                        <a:t>Not spatial; few South Asian instruments</a:t>
+                        <a:t>Not spatial; taps on glass rather than playing a kit</a:t>
                       </a:r>
                       <a:endParaRPr lang="en-US" sz="1300" dirty="0"/>
                     </a:p>
@@ -7533,6 +7601,10 @@
             <a:prstDash val="solid"/>
           </a:ln>
         </p:spPr>
+        <p:txBody>
+          <a:bodyPr/>
+          <a:p/>
+        </p:txBody>
       </p:sp>
       <p:sp>
         <p:nvSpPr>
@@ -7603,7 +7675,7 @@
                   <a:schemeClr val="tx1"/>
                 </a:solidFill>
               </a:rPr>
-              <a:t>Free studio with two drums. Instrument packs (Kandyan, low-country, Tamil percussion) as one-time purchases.</a:t>
+              <a:t>Free studio with the drum kit and chord synth. Instrument packs (including Sri Lankan percussion) as one-time purchases.</a:t>
             </a:r>
             <a:endParaRPr lang="en-US" sz="1400" dirty="0"/>
           </a:p>

</xml_diff>

<commit_message>
Remove the Sri Lankan percussion; keep only the drum kit and chord synth
Co-Authored-By: Claude Sonnet 5.5 <noreply@anthropic.com>
Claude-Session: https://claude.ai/code/session_01AzxfnqnDqs4Fac34LnmeNV
</commit_message>
<xml_diff>
--- a/Docs/Pitch/SoundSpace-Pitch.pptx
+++ b/Docs/Pitch/SoundSpace-Pitch.pptx
@@ -3318,6 +3318,10 @@
             <a:prstDash val="solid"/>
           </a:ln>
         </p:spPr>
+        <p:txBody>
+          <a:bodyPr/>
+          <a:p/>
+        </p:txBody>
       </p:sp>
       <p:sp>
         <p:nvSpPr>
@@ -3697,7 +3701,7 @@
                 <a:ea typeface="Cambria" pitchFamily="34" charset="-122"/>
                 <a:cs typeface="Cambria" pitchFamily="34" charset="-120"/>
               </a:rPr>
-              <a:t>Keeping a living tradition playable</a:t>
+              <a:t>Making music practice playable anywhere</a:t>
             </a:r>
             <a:endParaRPr lang="en-US" sz="3600" dirty="0"/>
           </a:p>
@@ -3733,7 +3737,7 @@
                   <a:schemeClr val="accent2"/>
                 </a:solidFill>
               </a:rPr>
-              <a:t>Teaching intangible cultural heritage in a new way</a:t>
+              <a:t>A drum kit and chord synth in your own room</a:t>
             </a:r>
             <a:endParaRPr lang="en-US" sz="2000" dirty="0"/>
           </a:p>
@@ -3773,7 +3777,7 @@
                   <a:srgbClr val="FFFFFF"/>
                 </a:solidFill>
               </a:rPr>
-              <a:t>Partners: a music academy and a cultural organisation</a:t>
+              <a:t>Partners: a music school and a drum teacher</a:t>
             </a:r>
             <a:endParaRPr lang="en-US" sz="1800" dirty="0"/>
           </a:p>
@@ -3791,7 +3795,7 @@
                   <a:srgbClr val="FFFFFF"/>
                 </a:solidFill>
               </a:rPr>
-              <a:t>Funding: device testing, real drum recordings, three lesson packs</a:t>
+              <a:t>Funding: device testing, real drum and chord recordings, three lesson packs</a:t>
             </a:r>
             <a:endParaRPr lang="en-US" sz="1800" dirty="0"/>
           </a:p>
@@ -3809,7 +3813,7 @@
                   <a:srgbClr val="FFFFFF"/>
                 </a:solidFill>
               </a:rPr>
-              <a:t>Milestone: pilot in one school and one museum</a:t>
+              <a:t>Milestone: pilot in one school</a:t>
             </a:r>
             <a:endParaRPr lang="en-US" sz="1800" dirty="0"/>
           </a:p>
@@ -4689,7 +4693,7 @@
                   <a:schemeClr val="tx1"/>
                 </a:solidFill>
               </a:rPr>
-              <a:t>Each instrument is a sound source in 3D. Walk around and the sound stays where the drum is.</a:t>
+              <a:t>Each instrument is a sound source in 3D. Walk around and the sound stays where the kit is.</a:t>
             </a:r>
             <a:endParaRPr lang="en-US" sz="1400" dirty="0"/>
           </a:p>
@@ -6713,7 +6717,7 @@
                             <a:schemeClr val="tx1"/>
                           </a:solidFill>
                         </a:rPr>
-                        <a:t>Few traditional instruments; no chord-and-drum jamming</a:t>
+                        <a:t>No drum kit or chord-and-drum jamming</a:t>
                       </a:r>
                       <a:endParaRPr lang="en-US" sz="1300" dirty="0"/>
                     </a:p>
@@ -7675,7 +7679,7 @@
                   <a:schemeClr val="tx1"/>
                 </a:solidFill>
               </a:rPr>
-              <a:t>Free studio with the drum kit and chord synth. Instrument packs (including Sri Lankan percussion) as one-time purchases.</a:t>
+              <a:t>Free studio with the drum kit and chord synth. Extra kits and sound packs (rock, jazz, electronic) as one-time purchases.</a:t>
             </a:r>
             <a:endParaRPr lang="en-US" sz="1400" dirty="0"/>
           </a:p>
@@ -7707,6 +7711,10 @@
             <a:prstDash val="solid"/>
           </a:ln>
         </p:spPr>
+        <p:txBody>
+          <a:bodyPr/>
+          <a:p/>
+        </p:txBody>
       </p:sp>
       <p:sp>
         <p:nvSpPr>
@@ -7809,6 +7817,10 @@
             <a:prstDash val="solid"/>
           </a:ln>
         </p:spPr>
+        <p:txBody>
+          <a:bodyPr/>
+          <a:p/>
+        </p:txBody>
       </p:sp>
       <p:sp>
         <p:nvSpPr>
@@ -8018,6 +8030,10 @@
             <a:prstDash val="solid"/>
           </a:ln>
         </p:spPr>
+        <p:txBody>
+          <a:bodyPr/>
+          <a:p/>
+        </p:txBody>
       </p:sp>
       <p:sp>
         <p:nvSpPr>
@@ -8124,7 +8140,7 @@
                   <a:schemeClr val="tx1"/>
                 </a:solidFill>
               </a:rPr>
-              <a:t>A music academy for authentic content and credibility</a:t>
+              <a:t>A music school for lesson content and credibility</a:t>
             </a:r>
             <a:endParaRPr lang="en-US" sz="1400" dirty="0"/>
           </a:p>
@@ -8154,6 +8170,10 @@
             <a:prstDash val="solid"/>
           </a:ln>
         </p:spPr>
+        <p:txBody>
+          <a:bodyPr/>
+          <a:p/>
+        </p:txBody>
       </p:sp>
       <p:sp>
         <p:nvSpPr>
@@ -8260,7 +8280,7 @@
                   <a:schemeClr val="tx1"/>
                 </a:solidFill>
               </a:rPr>
-              <a:t>Demos at cultural events and exhibitions</a:t>
+              <a:t>Demos at music events and exhibitions</a:t>
             </a:r>
             <a:endParaRPr lang="en-US" sz="1400" dirty="0"/>
           </a:p>
@@ -8290,6 +8310,10 @@
             <a:prstDash val="solid"/>
           </a:ln>
         </p:spPr>
+        <p:txBody>
+          <a:bodyPr/>
+          <a:p/>
+        </p:txBody>
       </p:sp>
       <p:sp>
         <p:nvSpPr>
@@ -8396,7 +8420,7 @@
                   <a:schemeClr val="tx1"/>
                 </a:solidFill>
               </a:rPr>
-              <a:t>Diaspora communities online</a:t>
+              <a:t>Drummers and bedroom musicians online</a:t>
             </a:r>
             <a:endParaRPr lang="en-US" sz="1400" dirty="0"/>
           </a:p>
@@ -8426,6 +8450,10 @@
             <a:prstDash val="solid"/>
           </a:ln>
         </p:spPr>
+        <p:txBody>
+          <a:bodyPr/>
+          <a:p/>
+        </p:txBody>
       </p:sp>
       <p:sp>
         <p:nvSpPr>
@@ -8532,7 +8560,7 @@
                   <a:schemeClr val="tx1"/>
                 </a:solidFill>
               </a:rPr>
-              <a:t>Around Vesak and Esala Perahera season</a:t>
+              <a:t>Alongside the next Vision Pro release window</a:t>
             </a:r>
             <a:endParaRPr lang="en-US" sz="1400" dirty="0"/>
           </a:p>

</xml_diff>